<commit_message>
Ajusta estructura del informe y avanza la presentación de avances
Informe: quita resumen, palabras clave y listas de figuras y tablas, y
reordena las secciones según la pauta: Introducción, Proceso
investigativo (con el levantamiento de la información), Desarrollo,
Conclusiones generales y Conclusiones específicas.

Presentación: completa el texto de las láminas con los datos del
proyecto (curso, profesora, temática, hitos, datos de la investigación,
herramienta, Gantt, dificultades y próximos pasos) sin cambiar el
diseño. Las barras "programado" de la Gantt quedan al 2 de noviembre.
Lo que depende de la encuesta o del avance real queda entre corchetes.

Co-Authored-By: Claude Opus 5.5 <noreply@anthropic.com>
</commit_message>
<xml_diff>
--- a/Envejecer_Mejor_avances.pptx
+++ b/Envejecer_Mejor_avances.pptx
@@ -5241,7 +5241,7 @@
                 <a:cs typeface="Arial Rounded"/>
                 <a:sym typeface="Arial Rounded"/>
               </a:rPr>
-              <a:t>presentación de avances · [nombre del curso] · </a:t>
+              <a:t>presentación de avances · Taller de Liderazgo · </a:t>
             </a:r>
             <a:r>
               <a:rPr b="1" lang="en-US" sz="1300">
@@ -5481,7 +5481,7 @@
                 <a:cs typeface="Arial Rounded"/>
                 <a:sym typeface="Arial Rounded"/>
               </a:rPr>
-              <a:t>[Profesor/a]</a:t>
+              <a:t>Prof. María José Herrera</a:t>
             </a:r>
             <a:endParaRPr b="0" i="0" sz="1300" u="none" cap="none" strike="noStrike">
               <a:solidFill>
@@ -5595,7 +5595,7 @@
                 <a:cs typeface="Calibri"/>
                 <a:sym typeface="Calibri"/>
               </a:rPr>
-              <a:t>[Una frase que resuma el proyecto: qué problema abordan, para quién y qué proponen]  &lt;3</a:t>
+              <a:t>Queremos que las personas de 40 a 59 años conozcan los hábitos que ayudan a llegar sanas a la vejez  &lt;3</a:t>
             </a:r>
             <a:endParaRPr b="0" i="0" sz="1400" u="none" cap="none" strike="noStrike">
               <a:solidFill>
@@ -6984,7 +6984,7 @@
                   <a:schemeClr val="dk1"/>
                 </a:solidFill>
               </a:rPr>
-              <a:t>[Una línea: Envejecer Mejor busca…]</a:t>
+              <a:t>Envejecer Mejor busca que más personas lleguen sanas a la tercera edad</a:t>
             </a:r>
             <a:endParaRPr sz="1500"/>
           </a:p>
@@ -7269,7 +7269,7 @@
                 <a:cs typeface="Calibri"/>
                 <a:sym typeface="Calibri"/>
               </a:rPr>
-              <a:t>[Describe en 1–2 líneas el problema que abordan]</a:t>
+              <a:t>Muchos llegan a la vejez con enfermedades crónicas que se podían prevenir con hábitos</a:t>
             </a:r>
             <a:endParaRPr b="0" i="0" sz="1400" u="none" cap="none" strike="noStrike">
               <a:solidFill>
@@ -7484,7 +7484,7 @@
                 <a:cs typeface="Calibri"/>
                 <a:sym typeface="Calibri"/>
               </a:rPr>
-              <a:t>[Objetivo general del proyecto en una frase]</a:t>
+              <a:t>Informar qué hábitos ayudan a envejecer sano, con material respaldado por evidencia</a:t>
             </a:r>
             <a:endParaRPr b="0" i="0" sz="1400" u="none" cap="none" strike="noStrike">
               <a:solidFill>
@@ -7699,7 +7699,7 @@
                 <a:cs typeface="Calibri"/>
                 <a:sym typeface="Calibri"/>
               </a:rPr>
-              <a:t>[Usuario objetivo: personas mayores, cuidadores, etc.]</a:t>
+              <a:t>Personas de 40 a 59 años y, en segundo lugar, mayores de 60</a:t>
             </a:r>
             <a:endParaRPr b="0" i="0" sz="1400" u="none" cap="none" strike="noStrike">
               <a:solidFill>
@@ -8033,7 +8033,7 @@
                 <a:cs typeface="Arial Rounded"/>
                 <a:sym typeface="Arial Rounded"/>
               </a:rPr>
-              <a:t>[Semana 1]</a:t>
+              <a:t>30 sep</a:t>
             </a:r>
             <a:endParaRPr b="0" i="0" sz="1100" u="none" cap="none" strike="noStrike">
               <a:solidFill>
@@ -8174,7 +8174,7 @@
                 <a:cs typeface="Arial Rounded"/>
                 <a:sym typeface="Arial Rounded"/>
               </a:rPr>
-              <a:t>[Hito 1]</a:t>
+              <a:t>Planificación</a:t>
             </a:r>
             <a:endParaRPr b="0" i="0" sz="1400" u="none" cap="none" strike="noStrike">
               <a:solidFill>
@@ -8211,7 +8211,7 @@
                 <a:cs typeface="Calibri"/>
                 <a:sym typeface="Calibri"/>
               </a:rPr>
-              <a:t>[Qué se entregó o logró]</a:t>
+              <a:t>Tareas, Gantt, matriz RACI y horas</a:t>
             </a:r>
             <a:endParaRPr b="0" i="0" sz="1400" u="none" cap="none" strike="noStrike">
               <a:solidFill>
@@ -8433,7 +8433,7 @@
                 <a:cs typeface="Arial Rounded"/>
                 <a:sym typeface="Arial Rounded"/>
               </a:rPr>
-              <a:t>[Semana 2]</a:t>
+              <a:t>5 oct</a:t>
             </a:r>
             <a:endParaRPr b="0" i="0" sz="1100" u="none" cap="none" strike="noStrike">
               <a:solidFill>
@@ -8574,7 +8574,7 @@
                 <a:cs typeface="Arial Rounded"/>
                 <a:sym typeface="Arial Rounded"/>
               </a:rPr>
-              <a:t>[Hito 2]</a:t>
+              <a:t>Herramienta</a:t>
             </a:r>
             <a:endParaRPr b="0" i="0" sz="1400" u="none" cap="none" strike="noStrike">
               <a:solidFill>
@@ -8611,7 +8611,7 @@
                 <a:cs typeface="Calibri"/>
                 <a:sym typeface="Calibri"/>
               </a:rPr>
-              <a:t>[Qué se entregó o logró]</a:t>
+              <a:t>Público 40–59, búsqueda y ficha</a:t>
             </a:r>
             <a:endParaRPr b="0" i="0" sz="1400" u="none" cap="none" strike="noStrike">
               <a:solidFill>
@@ -8833,7 +8833,7 @@
                 <a:cs typeface="Arial Rounded"/>
                 <a:sym typeface="Arial Rounded"/>
               </a:rPr>
-              <a:t>[Semana 3]</a:t>
+              <a:t>19 oct</a:t>
             </a:r>
             <a:endParaRPr b="0" i="0" sz="1100" u="none" cap="none" strike="noStrike">
               <a:solidFill>
@@ -8974,7 +8974,7 @@
                 <a:cs typeface="Arial Rounded"/>
                 <a:sym typeface="Arial Rounded"/>
               </a:rPr>
-              <a:t>[Hito 3]</a:t>
+              <a:t>Investigación</a:t>
             </a:r>
             <a:endParaRPr b="0" i="0" sz="1400" u="none" cap="none" strike="noStrike">
               <a:solidFill>
@@ -9011,7 +9011,7 @@
                 <a:cs typeface="Calibri"/>
                 <a:sym typeface="Calibri"/>
               </a:rPr>
-              <a:t>[Qué se entregó o logró]</a:t>
+              <a:t>11 papers leídos y fichados</a:t>
             </a:r>
             <a:endParaRPr b="0" i="0" sz="1400" u="none" cap="none" strike="noStrike">
               <a:solidFill>
@@ -9233,7 +9233,7 @@
                 <a:cs typeface="Arial Rounded"/>
                 <a:sym typeface="Arial Rounded"/>
               </a:rPr>
-              <a:t>[Semana 4]</a:t>
+              <a:t>[fecha]</a:t>
             </a:r>
             <a:endParaRPr b="0" i="0" sz="1100" u="none" cap="none" strike="noStrike">
               <a:solidFill>
@@ -9374,7 +9374,7 @@
                 <a:cs typeface="Arial Rounded"/>
                 <a:sym typeface="Arial Rounded"/>
               </a:rPr>
-              <a:t>[Hito 4]</a:t>
+              <a:t>Encuesta</a:t>
             </a:r>
             <a:endParaRPr b="0" i="0" sz="1400" u="none" cap="none" strike="noStrike">
               <a:solidFill>
@@ -9411,7 +9411,7 @@
                 <a:cs typeface="Calibri"/>
                 <a:sym typeface="Calibri"/>
               </a:rPr>
-              <a:t>[Qué se entregó o logró]</a:t>
+              <a:t>Formulario de 26 preguntas publicado</a:t>
             </a:r>
             <a:endParaRPr b="0" i="0" sz="1400" u="none" cap="none" strike="noStrike">
               <a:solidFill>
@@ -9891,7 +9891,7 @@
                 <a:cs typeface="Arial Rounded"/>
                 <a:sym typeface="Arial Rounded"/>
               </a:rPr>
-              <a:t>[XX%]</a:t>
+              <a:t>29,1 %</a:t>
             </a:r>
             <a:endParaRPr b="0" i="0" sz="3600" u="none" cap="none" strike="noStrike">
               <a:solidFill>
@@ -9954,7 +9954,7 @@
                 <a:cs typeface="Calibri"/>
                 <a:sym typeface="Calibri"/>
               </a:rPr>
-              <a:t>[Qué representa este dato]</a:t>
+              <a:t>tenía 2 o más enfermedades crónicas en 2020</a:t>
             </a:r>
             <a:endParaRPr b="0" i="0" sz="1400" u="none" cap="none" strike="noStrike">
               <a:solidFill>
@@ -10017,7 +10017,7 @@
                 <a:cs typeface="Calibri"/>
                 <a:sym typeface="Calibri"/>
               </a:rPr>
-              <a:t>Fuente: [autor, año]</a:t>
+              <a:t>Fuente: Zhu et al., 2025</a:t>
             </a:r>
             <a:endParaRPr b="0" i="0" sz="1000" u="none" cap="none" strike="noStrike">
               <a:solidFill>
@@ -10195,7 +10195,7 @@
                 <a:cs typeface="Arial Rounded"/>
                 <a:sym typeface="Arial Rounded"/>
               </a:rPr>
-              <a:t>[XX%]</a:t>
+              <a:t>4×</a:t>
             </a:r>
             <a:endParaRPr b="0" i="0" sz="3600" u="none" cap="none" strike="noStrike">
               <a:solidFill>
@@ -10258,7 +10258,7 @@
                 <a:cs typeface="Calibri"/>
                 <a:sym typeface="Calibri"/>
               </a:rPr>
-              <a:t>[Qué representa este dato]</a:t>
+              <a:t>más chances de envejecer bien con 5 hábitos sanos</a:t>
             </a:r>
             <a:endParaRPr b="0" i="0" sz="1400" u="none" cap="none" strike="noStrike">
               <a:solidFill>
@@ -10321,7 +10321,7 @@
                 <a:cs typeface="Calibri"/>
                 <a:sym typeface="Calibri"/>
               </a:rPr>
-              <a:t>Fuente: [autor, año]</a:t>
+              <a:t>Fuente: Bosnes et al., 2019</a:t>
             </a:r>
             <a:endParaRPr b="0" i="0" sz="1000" u="none" cap="none" strike="noStrike">
               <a:solidFill>
@@ -10562,7 +10562,7 @@
                 <a:cs typeface="Calibri"/>
                 <a:sym typeface="Calibri"/>
               </a:rPr>
-              <a:t>[Qué representa este dato]</a:t>
+              <a:t>[dato de la encuesta, p. ej. barrera principal]</a:t>
             </a:r>
             <a:endParaRPr b="0" i="0" sz="1400" u="none" cap="none" strike="noStrike">
               <a:solidFill>
@@ -10625,7 +10625,7 @@
                 <a:cs typeface="Calibri"/>
                 <a:sym typeface="Calibri"/>
               </a:rPr>
-              <a:t>Fuente: [autor, año]</a:t>
+              <a:t>Fuente: encuesta propia (n = [N])</a:t>
             </a:r>
             <a:endParaRPr b="0" i="0" sz="1000" u="none" cap="none" strike="noStrike">
               <a:solidFill>
@@ -10778,7 +10778,7 @@
                 <a:cs typeface="Calibri"/>
                 <a:sym typeface="Calibri"/>
               </a:rPr>
-              <a:t>[qué conclusión sacamos de estos datos para el proyecto]</a:t>
+              <a:t>actuar antes de que aparezcan las enfermedades: los hábitos sanos se suman</a:t>
             </a:r>
             <a:endParaRPr b="0" i="0" sz="1400" u="none" cap="none" strike="noStrike">
               <a:solidFill>
@@ -10980,7 +10980,7 @@
                   <a:schemeClr val="dk1"/>
                 </a:solidFill>
               </a:rPr>
-              <a:t>[Nombre de la herramienta o prototipo]</a:t>
+              <a:t>Herramienta de recolección de datos (5 de octubre)</a:t>
             </a:r>
             <a:endParaRPr sz="1500"/>
           </a:p>
@@ -11234,7 +11234,7 @@
                 <a:cs typeface="Arial Rounded"/>
                 <a:sym typeface="Arial Rounded"/>
               </a:rPr>
-              <a:t>[Resultado / funcionalidad 1]</a:t>
+              <a:t>Ecuación de búsqueda</a:t>
             </a:r>
             <a:endParaRPr b="0" i="0" sz="1300" u="none" cap="none" strike="noStrike">
               <a:solidFill>
@@ -11271,7 +11271,7 @@
                 <a:cs typeface="Calibri"/>
                 <a:sym typeface="Calibri"/>
               </a:rPr>
-              <a:t>[Qué permite hacer o qué obtuvimos]</a:t>
+              <a:t>24 papers identificados y 11 leídos completos</a:t>
             </a:r>
             <a:endParaRPr b="0" i="0" sz="1300" u="none" cap="none" strike="noStrike">
               <a:solidFill>
@@ -11455,7 +11455,7 @@
                 <a:cs typeface="Arial Rounded"/>
                 <a:sym typeface="Arial Rounded"/>
               </a:rPr>
-              <a:t>[Resultado / funcionalidad 2]</a:t>
+              <a:t>Ficha común</a:t>
             </a:r>
             <a:endParaRPr b="0" i="0" sz="1300" u="none" cap="none" strike="noStrike">
               <a:solidFill>
@@ -11492,7 +11492,7 @@
                 <a:cs typeface="Calibri"/>
                 <a:sym typeface="Calibri"/>
               </a:rPr>
-              <a:t>[Qué permite hacer o qué obtuvimos]</a:t>
+              <a:t>Población, diseño, hábito, resultado y dato útil</a:t>
             </a:r>
             <a:endParaRPr b="0" i="0" sz="1300" u="none" cap="none" strike="noStrike">
               <a:solidFill>
@@ -11676,7 +11676,7 @@
                 <a:cs typeface="Arial Rounded"/>
                 <a:sym typeface="Arial Rounded"/>
               </a:rPr>
-              <a:t>[Resultado / funcionalidad 3]</a:t>
+              <a:t>Encuesta de 26 preguntas</a:t>
             </a:r>
             <a:endParaRPr b="0" i="0" sz="1300" u="none" cap="none" strike="noStrike">
               <a:solidFill>
@@ -11713,7 +11713,7 @@
                 <a:cs typeface="Calibri"/>
                 <a:sym typeface="Calibri"/>
               </a:rPr>
-              <a:t>[Qué permite hacer o qué obtuvimos]</a:t>
+              <a:t>Rutina, barreras y fuentes: [N] respuestas</a:t>
             </a:r>
             <a:endParaRPr b="0" i="0" sz="1300" u="none" cap="none" strike="noStrike">
               <a:solidFill>
@@ -11915,7 +11915,7 @@
                   <a:schemeClr val="dk1"/>
                 </a:solidFill>
               </a:rPr>
-              <a:t>Programado vs. real a la fecha [dd/mm]</a:t>
+              <a:t>Programado vs. real al 02/11</a:t>
             </a:r>
             <a:endParaRPr sz="1500"/>
           </a:p>
@@ -12243,7 +12243,7 @@
                 <a:cs typeface="Calibri"/>
                 <a:sym typeface="Calibri"/>
               </a:rPr>
-              <a:t>[Actividad 1]</a:t>
+              <a:t>Rango etario</a:t>
             </a:r>
             <a:endParaRPr b="0" i="0" sz="1400" u="none" cap="none" strike="noStrike">
               <a:solidFill>
@@ -12510,7 +12510,7 @@
                 <a:cs typeface="Calibri"/>
                 <a:sym typeface="Calibri"/>
               </a:rPr>
-              <a:t>[Actividad 2]</a:t>
+              <a:t>Investigación</a:t>
             </a:r>
             <a:endParaRPr b="0" i="0" sz="1400" u="none" cap="none" strike="noStrike">
               <a:solidFill>
@@ -12777,7 +12777,7 @@
                 <a:cs typeface="Calibri"/>
                 <a:sym typeface="Calibri"/>
               </a:rPr>
-              <a:t>[Actividad 3]</a:t>
+              <a:t>Mensajes y formato</a:t>
             </a:r>
             <a:endParaRPr b="0" i="0" sz="1400" u="none" cap="none" strike="noStrike">
               <a:solidFill>
@@ -12845,7 +12845,7 @@
         <p:spPr>
           <a:xfrm>
             <a:off x="2514600" y="3035808"/>
-            <a:ext cx="2157984" cy="256032"/>
+            <a:ext cx="2697480" cy="256032"/>
           </a:xfrm>
           <a:prstGeom prst="roundRect">
             <a:avLst>
@@ -13044,7 +13044,7 @@
                 <a:cs typeface="Calibri"/>
                 <a:sym typeface="Calibri"/>
               </a:rPr>
-              <a:t>[Actividad 4]</a:t>
+              <a:t>Afiches y posts</a:t>
             </a:r>
             <a:endParaRPr b="0" i="0" sz="1400" u="none" cap="none" strike="noStrike">
               <a:solidFill>
@@ -13112,7 +13112,7 @@
         <p:spPr>
           <a:xfrm>
             <a:off x="2514600" y="3483864"/>
-            <a:ext cx="1618488" cy="256032"/>
+            <a:ext cx="2697480" cy="256032"/>
           </a:xfrm>
           <a:prstGeom prst="roundRect">
             <a:avLst>
@@ -13311,7 +13311,7 @@
                 <a:cs typeface="Calibri"/>
                 <a:sym typeface="Calibri"/>
               </a:rPr>
-              <a:t>[Actividad 5]</a:t>
+              <a:t>Página web</a:t>
             </a:r>
             <a:endParaRPr b="0" i="0" sz="1400" u="none" cap="none" strike="noStrike">
               <a:solidFill>
@@ -13379,7 +13379,7 @@
         <p:spPr>
           <a:xfrm>
             <a:off x="2514600" y="3931920"/>
-            <a:ext cx="809244" cy="256032"/>
+            <a:ext cx="1672438" cy="256032"/>
           </a:xfrm>
           <a:prstGeom prst="roundRect">
             <a:avLst>
@@ -14236,7 +14236,7 @@
                 <a:cs typeface="Calibri"/>
                 <a:sym typeface="Calibri"/>
               </a:rPr>
-              <a:t>[Qué problema tuvimos]</a:t>
+              <a:t>Búsqueda con pocos o muchos papers</a:t>
             </a:r>
             <a:endParaRPr b="0" i="0" sz="1300" u="none" cap="none" strike="noStrike">
               <a:solidFill>
@@ -14478,7 +14478,7 @@
                 <a:cs typeface="Calibri"/>
                 <a:sym typeface="Calibri"/>
               </a:rPr>
-              <a:t>[Acción concreta que tomamos]</a:t>
+              <a:t>Ajustamos la ecuación por bloques</a:t>
             </a:r>
             <a:endParaRPr b="0" i="0" sz="1300" u="none" cap="none" strike="noStrike">
               <a:solidFill>
@@ -14693,7 +14693,7 @@
                 <a:cs typeface="Calibri"/>
                 <a:sym typeface="Calibri"/>
               </a:rPr>
-              <a:t>[Qué problema tuvimos]</a:t>
+              <a:t>13 de 24 papers sin texto completo</a:t>
             </a:r>
             <a:endParaRPr b="0" i="0" sz="1300" u="none" cap="none" strike="noStrike">
               <a:solidFill>
@@ -14935,7 +14935,7 @@
                 <a:cs typeface="Calibri"/>
                 <a:sym typeface="Calibri"/>
               </a:rPr>
-              <a:t>[Acción concreta que tomamos]</a:t>
+              <a:t>Usamos solo los 11 leídos completos</a:t>
             </a:r>
             <a:endParaRPr b="0" i="0" sz="1300" u="none" cap="none" strike="noStrike">
               <a:solidFill>
@@ -15150,7 +15150,7 @@
                 <a:cs typeface="Calibri"/>
                 <a:sym typeface="Calibri"/>
               </a:rPr>
-              <a:t>[Qué problema tuvimos]</a:t>
+              <a:t>Solo 3 a 5 horas por persona/semana</a:t>
             </a:r>
             <a:endParaRPr b="0" i="0" sz="1300" u="none" cap="none" strike="noStrike">
               <a:solidFill>
@@ -15392,7 +15392,7 @@
                 <a:cs typeface="Calibri"/>
                 <a:sym typeface="Calibri"/>
               </a:rPr>
-              <a:t>[Acción concreta que tomamos]</a:t>
+              <a:t>Tareas en paralelo y 5 días de holgura</a:t>
             </a:r>
             <a:endParaRPr b="0" i="0" sz="1300" u="none" cap="none" strike="noStrike">
               <a:solidFill>
@@ -15606,7 +15606,7 @@
                   <a:schemeClr val="dk1"/>
                 </a:solidFill>
               </a:rPr>
-              <a:t>Envejecer Mejor · [Integrantes]</a:t>
+              <a:t>Envejecer Mejor · Ulysses, Lucas, Valentina, Maximiliano y Fabián</a:t>
             </a:r>
             <a:endParaRPr sz="1500"/>
           </a:p>
@@ -15859,7 +15859,7 @@
                 <a:cs typeface="Arial Rounded"/>
                 <a:sym typeface="Arial Rounded"/>
               </a:rPr>
-              <a:t>[Próximo hito 1]</a:t>
+              <a:t>Terminar la página web</a:t>
             </a:r>
             <a:endParaRPr b="0" i="0" sz="1300" u="none" cap="none" strike="noStrike">
               <a:solidFill>
@@ -15896,7 +15896,7 @@
                 <a:cs typeface="Calibri"/>
                 <a:sym typeface="Calibri"/>
               </a:rPr>
-              <a:t>[Fecha según Gantt]</a:t>
+              <a:t>10 de noviembre</a:t>
             </a:r>
             <a:endParaRPr b="0" i="0" sz="1300" u="none" cap="none" strike="noStrike">
               <a:solidFill>
@@ -16094,7 +16094,7 @@
                 <a:cs typeface="Arial Rounded"/>
                 <a:sym typeface="Arial Rounded"/>
               </a:rPr>
-              <a:t>[Próximo hito 2]</a:t>
+              <a:t>Difundir el material</a:t>
             </a:r>
             <a:endParaRPr b="0" i="0" sz="1300" u="none" cap="none" strike="noStrike">
               <a:solidFill>
@@ -16131,7 +16131,7 @@
                 <a:cs typeface="Calibri"/>
                 <a:sym typeface="Calibri"/>
               </a:rPr>
-              <a:t>[Fecha según Gantt]</a:t>
+              <a:t>4 al 15 de noviembre</a:t>
             </a:r>
             <a:endParaRPr b="0" i="0" sz="1300" u="none" cap="none" strike="noStrike">
               <a:solidFill>
@@ -16329,7 +16329,7 @@
                 <a:cs typeface="Arial Rounded"/>
                 <a:sym typeface="Arial Rounded"/>
               </a:rPr>
-              <a:t>[Próximo hito 3]</a:t>
+              <a:t>Entregar el informe final</a:t>
             </a:r>
             <a:endParaRPr b="0" i="0" sz="1300" u="none" cap="none" strike="noStrike">
               <a:solidFill>
@@ -16366,7 +16366,7 @@
                 <a:cs typeface="Calibri"/>
                 <a:sym typeface="Calibri"/>
               </a:rPr>
-              <a:t>[Fecha según Gantt]</a:t>
+              <a:t>23 de noviembre</a:t>
             </a:r>
             <a:endParaRPr b="0" i="0" sz="1300" u="none" cap="none" strike="noStrike">
               <a:solidFill>

</xml_diff>

<commit_message>
Agrega logo y cuenta de Instagram a la presentación y al informe
La portada de la presentación usa el logo del proyecto en el círculo de
la plantilla, y la última lámina muestra @envejecer.mejor como contacto.
El informe nombra la cuenta de Instagram en la propuesta de difusión.

Co-Authored-By: Claude Opus 5.5 <noreply@anthropic.com>
</commit_message>
<xml_diff>
--- a/Envejecer_Mejor_avances.pptx
+++ b/Envejecer_Mejor_avances.pptx
@@ -4624,7 +4624,7 @@
       </p:sp>
       <p:pic>
         <p:nvPicPr>
-          <p:cNvPr descr="img/ph_avatar.png" id="26" name="Google Shape;26;p5"/>
+          <p:cNvPr descr="Logo de Envejecer Mejor" id="26" name="Google Shape;26;p5"/>
           <p:cNvPicPr preferRelativeResize="0"/>
           <p:nvPr/>
         </p:nvPicPr>
@@ -4632,7 +4632,7 @@
           <a:blip r:embed="rId3">
             <a:alphaModFix/>
           </a:blip>
-          <a:srcRect b="0" l="0" r="0" t="0"/>
+          <a:srcRect b="11250" l="11250" r="11250" t="11250"/>
           <a:stretch/>
         </p:blipFill>
         <p:spPr>
@@ -16582,7 +16582,7 @@
                 <a:cs typeface="Arial Rounded"/>
                 <a:sym typeface="Arial Rounded"/>
               </a:rPr>
-              <a:t>[correo / contacto]</a:t>
+              <a:t>@envejecer.mejor</a:t>
             </a:r>
             <a:endParaRPr b="0" i="0" sz="1300" u="none" cap="none" strike="noStrike">
               <a:solidFill>

</xml_diff>